<commit_message>
Correct speaker notes and add opening-report Q and A.
Notes no longer treat motive as the test of localization, and they no
longer invite HSK-fit scoring as the study. A short question sheet
matches the locked terms, refusals, and likely committee challenges.

Co-authored-by: kristinehina23-rgb <kristinehina23-rgb@users.noreply.github.com>
</commit_message>
<xml_diff>
--- a/proposal/PhD-research-proposal.pptx
+++ b/proposal/PhD-research-proposal.pptx
@@ -772,43 +772,19 @@
               </a:lnSpc>
             </a:pPr>
             <a:r>
-              <a:rPr lang="en-US" b="false" i="false" strike="noStrike" u="none" sz="1400">
-                <a:solidFill>
-                  <a:srgbClr val="000000"/>
-                </a:solidFill>
-              </a:rPr>
-              <a:t>Good morning, committee members. Thank you for the opportunity to present my PhD research proposal.</a:t>
-            </a:r>
-          </a:p>
-          <a:p>
-            <a:pPr algn="l" marL="0" indent="0">
-              <a:lnSpc>
-                <a:spcPct val="100000"/>
-              </a:lnSpc>
-            </a:pPr>
-            <a:r>
-              <a:rPr lang="en-US" b="false" i="false" strike="noStrike" u="none" sz="1400">
-                <a:solidFill>
-                  <a:srgbClr val="000000"/>
-                </a:solidFill>
-              </a:rPr>
-              <a:t>The study examines how Pakistani teachers of Chinese actually rework published teaching materials in their classrooms, and how their professional agency is enabled or constrained by the conditions of their work.</a:t>
-            </a:r>
-          </a:p>
-          <a:p>
-            <a:pPr algn="l" marL="0" indent="0">
-              <a:lnSpc>
-                <a:spcPct val="100000"/>
-              </a:lnSpc>
-            </a:pPr>
-            <a:r>
-              <a:rPr lang="en-US" b="false" i="false" strike="noStrike" u="none" sz="1400">
-                <a:solidFill>
-                  <a:srgbClr val="000000"/>
-                </a:solidFill>
-              </a:rPr>
-              <a:t>It is a qualitative, ecological study. I will walk you through the background, the gap, the questions, the design, and the anticipated contribution.</a:t>
-            </a:r>
+              <a:t>Good morning, committee members. Thank you for the opportunity to present this proposal.</a:t>
+            </a:r>
+            <a:br/>
+            <a:br/>
+            <a:r>
+              <a:t>The study asks how Pakistani teachers of Chinese recontextualize Chinese-language teaching materials in classroom practice, and how their agency is achieved or constrained in the conditions of their work.</a:t>
+            </a:r>
+            <a:br/>
+            <a:br/>
+            <a:r>
+              <a:t>It is a qualitative, ecological study. I will cover the problem, the gap, the questions, the design, and the contribution. I will not propose a new textbook, and I will not score HSK materials as a product.</a:t>
+            </a:r>
+            <a:br/>
           </a:p>
         </p:txBody>
       </p:sp>
@@ -1027,43 +1003,29 @@
               </a:lnSpc>
             </a:pPr>
             <a:r>
-              <a:rPr lang="en-US" b="false" i="false" strike="noStrike" u="none" sz="1400">
-                <a:solidFill>
-                  <a:srgbClr val="000000"/>
-                </a:solidFill>
-              </a:rPr>
-              <a:t>No single source is trusted alone. Comparing the prescribed page to the teacher's own materials shows the traces of change.</a:t>
-            </a:r>
-          </a:p>
-          <a:p>
-            <a:pPr algn="l" marL="0" indent="0">
-              <a:lnSpc>
-                <a:spcPct val="100000"/>
-              </a:lnSpc>
-            </a:pPr>
-            <a:r>
-              <a:rPr lang="en-US" b="false" i="false" strike="noStrike" u="none" sz="1400">
-                <a:solidFill>
-                  <a:srgbClr val="000000"/>
-                </a:solidFill>
-              </a:rPr>
-              <a:t>Observation shows the change as it happens. Lesson-focused interview and stimulated recall surface the reasoning tied to that actual lesson, not a general belief about localization.</a:t>
-            </a:r>
-          </a:p>
-          <a:p>
-            <a:pPr algn="l" marL="0" indent="0">
-              <a:lnSpc>
-                <a:spcPct val="100000"/>
-              </a:lnSpc>
-            </a:pPr>
-            <a:r>
-              <a:rPr lang="en-US" b="false" i="false" strike="noStrike" u="none" sz="1400">
-                <a:solidFill>
-                  <a:srgbClr val="000000"/>
-                </a:solidFill>
-              </a:rPr>
-              <a:t>Institutional field notes capture the conditions. Each source is mapped to the question it can actually answer.</a:t>
-            </a:r>
+              <a:t>No single source is trusted alone.</a:t>
+            </a:r>
+            <a:br/>
+            <a:br/>
+            <a:r>
+              <a:t>The prescribed page compared with slides, worksheets, and tests shows traces of what was added, cut, substituted, or reordered.</a:t>
+            </a:r>
+            <a:br/>
+            <a:br/>
+            <a:r>
+              <a:t>Observation shows the hour, including when the teacher follows the book closely.</a:t>
+            </a:r>
+            <a:br/>
+            <a:br/>
+            <a:r>
+              <a:t>The interview and stimulated recall are tied to that lesson, not to a general attitude toward localization.</a:t>
+            </a:r>
+            <a:br/>
+            <a:br/>
+            <a:r>
+              <a:t>Field notes capture who chooses the book, exam pressure, class size, and medium of instruction. Those conditions are part of agency, not background.</a:t>
+            </a:r>
+            <a:br/>
           </a:p>
         </p:txBody>
       </p:sp>
@@ -1282,58 +1244,24 @@
               </a:lnSpc>
             </a:pPr>
             <a:r>
-              <a:rPr lang="en-US" b="false" i="false" strike="noStrike" u="none" sz="1400">
-                <a:solidFill>
-                  <a:srgbClr val="000000"/>
-                </a:solidFill>
-              </a:rPr>
-              <a:t>Analysis moves in three deliberate passes. First, what the teacher actually did, coded against the real page.</a:t>
-            </a:r>
-          </a:p>
-          <a:p>
-            <a:pPr algn="l" marL="0" indent="0">
-              <a:lnSpc>
-                <a:spcPct val="100000"/>
-              </a:lnSpc>
-            </a:pPr>
-            <a:r>
-              <a:rPr lang="en-US" b="false" i="false" strike="noStrike" u="none" sz="1400">
-                <a:solidFill>
-                  <a:srgbClr val="000000"/>
-                </a:solidFill>
-              </a:rPr>
-              <a:t>Second, why, but as a judgement tied to that specific lesson — if a reason is only ever talked about and never observed, it is logged as talk, not as practice.</a:t>
-            </a:r>
-          </a:p>
-          <a:p>
-            <a:pPr algn="l" marL="0" indent="0">
-              <a:lnSpc>
-                <a:spcPct val="100000"/>
-              </a:lnSpc>
-            </a:pPr>
-            <a:r>
-              <a:rPr lang="en-US" b="false" i="false" strike="noStrike" u="none" sz="1400">
-                <a:solidFill>
-                  <a:srgbClr val="000000"/>
-                </a:solidFill>
-              </a:rPr>
-              <a:t>Third, agency across the three temporal dimensions. Restricted or addition-only work is coded as agency, not its absence.</a:t>
-            </a:r>
-          </a:p>
-          <a:p>
-            <a:pPr algn="l" marL="0" indent="0">
-              <a:lnSpc>
-                <a:spcPct val="100000"/>
-              </a:lnSpc>
-            </a:pPr>
-            <a:r>
-              <a:rPr lang="en-US" b="false" i="false" strike="noStrike" u="none" sz="1400">
-                <a:solidFill>
-                  <a:srgbClr val="000000"/>
-                </a:solidFill>
-              </a:rPr>
-              <a:t>Cases are analysed individually before any comparison across them.</a:t>
-            </a:r>
+              <a:t>Three analytic passes inside each case, then comparison across cases.</a:t>
+            </a:r>
+            <a:br/>
+            <a:br/>
+            <a:r>
+              <a:t>First, code the move against the page used that day. The list is a starting point, not a checklist of successful localization.</a:t>
+            </a:r>
+            <a:br/>
+            <a:br/>
+            <a:r>
+              <a:t>Second, code the reason as a judgement tied to that lesson. A reason that appears only in talk is recorded as talk, not as practice.</a:t>
+            </a:r>
+            <a:br/>
+            <a:br/>
+            <a:r>
+              <a:t>Third, read agency across the triad and the nested conditions. Restricted, addition-only, or compliant forms are named only if the case supports them. They describe a form of agency, not teacher quality.</a:t>
+            </a:r>
+            <a:br/>
           </a:p>
         </p:txBody>
       </p:sp>
@@ -1552,43 +1480,19 @@
               </a:lnSpc>
             </a:pPr>
             <a:r>
-              <a:rPr lang="en-US" b="false" i="false" strike="noStrike" u="none" sz="1400">
-                <a:solidFill>
-                  <a:srgbClr val="000000"/>
-                </a:solidFill>
-              </a:rPr>
-              <a:t>The procedure is sequential. Literature and framework come first, then ethics and a small pilot to refine the instruments.</a:t>
-            </a:r>
-          </a:p>
-          <a:p>
-            <a:pPr algn="l" marL="0" indent="0">
-              <a:lnSpc>
-                <a:spcPct val="100000"/>
-              </a:lnSpc>
-            </a:pPr>
-            <a:r>
-              <a:rPr lang="en-US" b="false" i="false" strike="noStrike" u="none" sz="1400">
-                <a:solidFill>
-                  <a:srgbClr val="000000"/>
-                </a:solidFill>
-              </a:rPr>
-              <a:t>Fieldwork moves teacher by teacher. Analysis follows the three passes I described. Writing closes on the title itself.</a:t>
-            </a:r>
-          </a:p>
-          <a:p>
-            <a:pPr algn="l" marL="0" indent="0">
-              <a:lnSpc>
-                <a:spcPct val="100000"/>
-              </a:lnSpc>
-            </a:pPr>
-            <a:r>
-              <a:rPr lang="en-US" b="false" i="false" strike="noStrike" u="none" sz="1400">
-                <a:solidFill>
-                  <a:srgbClr val="000000"/>
-                </a:solidFill>
-              </a:rPr>
-              <a:t>Two guardrails: nothing from the pilot is reported, and a site that will not allow observation is not converted into a survey.</a:t>
-            </a:r>
+              <a:t>The procedure is sequential. Literature and framework come first. Ethics, access, and a one-to-two teacher pilot come next. Instruments are revised before fieldwork.</a:t>
+            </a:r>
+            <a:br/>
+            <a:br/>
+            <a:r>
+              <a:t>Fieldwork moves teacher by teacher. Analysis follows the three passes. Writing returns to the title.</a:t>
+            </a:r>
+            <a:br/>
+            <a:br/>
+            <a:r>
+              <a:t>Two limits: pilot data are not findings. If a site refuses observation, that case is dropped or limited. It is not recoded as a survey.</a:t>
+            </a:r>
+            <a:br/>
           </a:p>
         </p:txBody>
       </p:sp>
@@ -1807,43 +1711,24 @@
               </a:lnSpc>
             </a:pPr>
             <a:r>
-              <a:rPr lang="en-US" b="false" i="false" strike="noStrike" u="none" sz="1400">
-                <a:solidFill>
-                  <a:srgbClr val="000000"/>
-                </a:solidFill>
-              </a:rPr>
-              <a:t>The thesis has seven chapters. The first four set up problem, literature, framework and design.</a:t>
-            </a:r>
-          </a:p>
-          <a:p>
-            <a:pPr algn="l" marL="0" indent="0">
-              <a:lnSpc>
-                <a:spcPct val="100000"/>
-              </a:lnSpc>
-            </a:pPr>
-            <a:r>
-              <a:rPr lang="en-US" b="false" i="false" strike="noStrike" u="none" sz="1400">
-                <a:solidFill>
-                  <a:srgbClr val="000000"/>
-                </a:solidFill>
-              </a:rPr>
-              <a:t>Two separate findings chapters answer RQ1, then RQ2 and RQ3. Keeping them apart mirrors the two objects in the title.</a:t>
-            </a:r>
-          </a:p>
-          <a:p>
-            <a:pPr algn="l" marL="0" indent="0">
-              <a:lnSpc>
-                <a:spcPct val="100000"/>
-              </a:lnSpc>
-            </a:pPr>
-            <a:r>
-              <a:rPr lang="en-US" b="false" i="false" strike="noStrike" u="none" sz="1400">
-                <a:solidFill>
-                  <a:srgbClr val="000000"/>
-                </a:solidFill>
-              </a:rPr>
-              <a:t>The final chapter returns to the title and states implications, limits and further research — without converting into a call for a new textbook.</a:t>
-            </a:r>
+              <a:t>Seven chapters. Two findings chapters because the title names two objects.</a:t>
+            </a:r>
+            <a:br/>
+            <a:br/>
+            <a:r>
+              <a:t>Chapter 5 answers RQ1: what was done with the page.</a:t>
+            </a:r>
+            <a:br/>
+            <a:br/>
+            <a:r>
+              <a:t>Chapter 6 answers RQ2 and RQ3: reasons, the agency triad, and conditions.</a:t>
+            </a:r>
+            <a:br/>
+            <a:br/>
+            <a:r>
+              <a:t>Localization is read from that practice. It does not get a third theory chapter. Chapter 7 does not become a proposal for a new textbook.</a:t>
+            </a:r>
+            <a:br/>
           </a:p>
         </p:txBody>
       </p:sp>
@@ -2062,43 +1947,19 @@
               </a:lnSpc>
             </a:pPr>
             <a:r>
-              <a:rPr lang="en-US" b="false" i="false" strike="noStrike" u="none" sz="1400">
-                <a:solidFill>
-                  <a:srgbClr val="000000"/>
-                </a:solidFill>
-              </a:rPr>
-              <a:t>The three foci follow directly from the title: the moves, the agency behind them, and localization as a classroom process.</a:t>
-            </a:r>
-          </a:p>
-          <a:p>
-            <a:pPr algn="l" marL="0" indent="0">
-              <a:lnSpc>
-                <a:spcPct val="100000"/>
-              </a:lnSpc>
-            </a:pPr>
-            <a:r>
-              <a:rPr lang="en-US" b="false" i="false" strike="noStrike" u="none" sz="1400">
-                <a:solidFill>
-                  <a:srgbClr val="000000"/>
-                </a:solidFill>
-              </a:rPr>
-              <a:t>The innovations are modest and honest. They are not new theories; they bring existing tools together on a population and a materials object that have not been studied this way.</a:t>
-            </a:r>
-          </a:p>
-          <a:p>
-            <a:pPr algn="l" marL="0" indent="0">
-              <a:lnSpc>
-                <a:spcPct val="100000"/>
-              </a:lnSpc>
-            </a:pPr>
-            <a:r>
-              <a:rPr lang="en-US" b="false" i="false" strike="noStrike" u="none" sz="1400">
-                <a:solidFill>
-                  <a:srgbClr val="000000"/>
-                </a:solidFill>
-              </a:rPr>
-              <a:t>The object, the method, and the analytic cut are the three points of novelty.</a:t>
-            </a:r>
+              <a:t>The three foci are the questions: the moves, the agency in conditions, and localization as classroom process rather than a new book.</a:t>
+            </a:r>
+            <a:br/>
+            <a:br/>
+            <a:r>
+              <a:t>The innovations are modest. They are a join, a method already used elsewhere, and an analytic cut, applied to this population. They are not new theories.</a:t>
+            </a:r>
+            <a:br/>
+            <a:br/>
+            <a:r>
+              <a:t>A CNKI search remains a limit. I will not claim a global first.</a:t>
+            </a:r>
+            <a:br/>
           </a:p>
         </p:txBody>
       </p:sp>
@@ -2317,43 +2178,19 @@
               </a:lnSpc>
             </a:pPr>
             <a:r>
-              <a:rPr lang="en-US" b="false" i="false" strike="noStrike" u="none" sz="1400">
-                <a:solidFill>
-                  <a:srgbClr val="000000"/>
-                </a:solidFill>
-              </a:rPr>
-              <a:t>Each difficulty is one that similar studies have already met, and the solution is borrowed from those studies.</a:t>
-            </a:r>
-          </a:p>
-          <a:p>
-            <a:pPr algn="l" marL="0" indent="0">
-              <a:lnSpc>
-                <a:spcPct val="100000"/>
-              </a:lnSpc>
-            </a:pPr>
-            <a:r>
-              <a:rPr lang="en-US" b="false" i="false" strike="noStrike" u="none" sz="1400">
-                <a:solidFill>
-                  <a:srgbClr val="000000"/>
-                </a:solidFill>
-              </a:rPr>
-              <a:t>Talk is not trusted as evidence; access risks are planned for; and crucially, conservative practice is treated as a finding about restriction, not as a failed study.</a:t>
-            </a:r>
-          </a:p>
-          <a:p>
-            <a:pPr algn="l" marL="0" indent="0">
-              <a:lnSpc>
-                <a:spcPct val="100000"/>
-              </a:lnSpc>
-            </a:pPr>
-            <a:r>
-              <a:rPr lang="en-US" b="false" i="false" strike="noStrike" u="none" sz="1400">
-                <a:solidFill>
-                  <a:srgbClr val="000000"/>
-                </a:solidFill>
-              </a:rPr>
-              <a:t>The study only fails if it cannot see practice — not if the practice turns out to be cautious.</a:t>
-            </a:r>
+              <a:t>Talk is not evidence of use. Neighbouring studies already show that stated willingness exceeds what is done. So I observe and compare the page.</a:t>
+            </a:r>
+            <a:br/>
+            <a:br/>
+            <a:r>
+              <a:t>Access may be refused near exams, and video may not be allowed. Ethics and access come first. Field notes or audio replace video if needed.</a:t>
+            </a:r>
+            <a:br/>
+            <a:br/>
+            <a:r>
+              <a:t>If classes stay close to an HSK sequence, a product-localization frame would call the study empty. This frame does not. Faithful transmission and addition-only work still count. Restricted agency still counts.</a:t>
+            </a:r>
+            <a:br/>
           </a:p>
         </p:txBody>
       </p:sp>
@@ -2572,43 +2409,19 @@
               </a:lnSpc>
             </a:pPr>
             <a:r>
-              <a:rPr lang="en-US" b="false" i="false" strike="noStrike" u="none" sz="1400">
-                <a:solidFill>
-                  <a:srgbClr val="000000"/>
-                </a:solidFill>
-              </a:rPr>
-              <a:t>On the theoretical side, the study brings classroom work into the picture and uses one analytic language for active and faithful teaching alike.</a:t>
-            </a:r>
-          </a:p>
-          <a:p>
-            <a:pPr algn="l" marL="0" indent="0">
-              <a:lnSpc>
-                <a:spcPct val="100000"/>
-              </a:lnSpc>
-            </a:pPr>
-            <a:r>
-              <a:rPr lang="en-US" b="false" i="false" strike="noStrike" u="none" sz="1400">
-                <a:solidFill>
-                  <a:srgbClr val="000000"/>
-                </a:solidFill>
-              </a:rPr>
-              <a:t>On the practical side, it gives teacher education and institutions something concrete to work with, and reminds them that some of the problem is institutional, not individual.</a:t>
-            </a:r>
-          </a:p>
-          <a:p>
-            <a:pPr algn="l" marL="0" indent="0">
-              <a:lnSpc>
-                <a:spcPct val="100000"/>
-              </a:lnSpc>
-            </a:pPr>
-            <a:r>
-              <a:rPr lang="en-US" b="false" i="false" strike="noStrike" u="none" sz="1400">
-                <a:solidFill>
-                  <a:srgbClr val="000000"/>
-                </a:solidFill>
-              </a:rPr>
-              <a:t>It deliberately stops short of recommending a new textbook as the answer.</a:t>
-            </a:r>
+              <a:t>Theoretically, the study brings classroom work into a localization literature that has centred textbook production, and it analyses faithful and reshaping teaching in the same ecological terms.</a:t>
+            </a:r>
+            <a:br/>
+            <a:br/>
+            <a:r>
+              <a:t>Practically, teacher education and universities can start from decisions already made under time, exams, and support, not only from a set book.</a:t>
+            </a:r>
+            <a:br/>
+            <a:br/>
+            <a:r>
+              <a:t>The study does not recommend a new national textbook as the automatic solution.</a:t>
+            </a:r>
+            <a:br/>
           </a:p>
         </p:txBody>
       </p:sp>
@@ -2827,28 +2640,14 @@
               </a:lnSpc>
             </a:pPr>
             <a:r>
-              <a:rPr lang="en-US" b="false" i="false" strike="noStrike" u="none" sz="1400">
-                <a:solidFill>
-                  <a:srgbClr val="000000"/>
-                </a:solidFill>
-              </a:rPr>
-              <a:t>The whole argument can be stated in one line: localization is not a future textbook, it is teacher-mediated recontextualization under ecological conditions.</a:t>
-            </a:r>
-          </a:p>
-          <a:p>
-            <a:pPr algn="l" marL="0" indent="0">
-              <a:lnSpc>
-                <a:spcPct val="100000"/>
-              </a:lnSpc>
-            </a:pPr>
-            <a:r>
-              <a:rPr lang="en-US" b="false" i="false" strike="noStrike" u="none" sz="1400">
-                <a:solidFill>
-                  <a:srgbClr val="000000"/>
-                </a:solidFill>
-              </a:rPr>
-              <a:t>The study delivers three things: an account of what teachers do, an ecological account of their agency, and a grounded view of how localization is actually produced or held back.</a:t>
-            </a:r>
+              <a:t>One line: localization is not a book to be written. It is produced, or blocked, in the classroom, under the conditions that shape teachers' work.</a:t>
+            </a:r>
+            <a:br/>
+            <a:br/>
+            <a:r>
+              <a:t>Not every recontextualizing move is localization. The study will show what Pakistani teachers of Chinese do with the materials actually in use, how agency is achieved or restricted, and whether teacher-mediated localization is produced or blocked in those classrooms.</a:t>
+            </a:r>
+            <a:br/>
           </a:p>
         </p:txBody>
       </p:sp>
@@ -3067,43 +2866,19 @@
               </a:lnSpc>
             </a:pPr>
             <a:r>
-              <a:rPr lang="en-US" b="false" i="false" strike="noStrike" u="none" sz="1400">
-                <a:solidFill>
-                  <a:srgbClr val="000000"/>
-                </a:solidFill>
-              </a:rPr>
-              <a:t>Thank you for your time and attention.</a:t>
-            </a:r>
-          </a:p>
-          <a:p>
-            <a:pPr algn="l" marL="0" indent="0">
-              <a:lnSpc>
-                <a:spcPct val="100000"/>
-              </a:lnSpc>
-            </a:pPr>
-            <a:r>
-              <a:rPr lang="en-US" b="false" i="false" strike="noStrike" u="none" sz="1400">
-                <a:solidFill>
-                  <a:srgbClr val="000000"/>
-                </a:solidFill>
-              </a:rPr>
-              <a:t>I would particularly value the committee's guidance on the case selection, the line between description and evaluation of HSK materials, and the practicalities of access.</a:t>
-            </a:r>
-          </a:p>
-          <a:p>
-            <a:pPr algn="l" marL="0" indent="0">
-              <a:lnSpc>
-                <a:spcPct val="100000"/>
-              </a:lnSpc>
-            </a:pPr>
-            <a:r>
-              <a:rPr lang="en-US" b="false" i="false" strike="noStrike" u="none" sz="1400">
-                <a:solidFill>
-                  <a:srgbClr val="000000"/>
-                </a:solidFill>
-              </a:rPr>
-              <a:t>I am happy to take questions.</a:t>
-            </a:r>
+              <a:t>Thank you.</a:t>
+            </a:r>
+            <a:br/>
+            <a:br/>
+            <a:r>
+              <a:t>I welcome questions on the framing, the case design, observation access, and the analytic distinction between recontextualization, agency, and localization.</a:t>
+            </a:r>
+            <a:br/>
+            <a:br/>
+            <a:r>
+              <a:t>I am not asking the committee to treat HSK-fit scoring as the study. HSK, where it appears, is a condition of teachers' work.</a:t>
+            </a:r>
+            <a:br/>
           </a:p>
         </p:txBody>
       </p:sp>
@@ -3322,28 +3097,14 @@
               </a:lnSpc>
             </a:pPr>
             <a:r>
-              <a:rPr lang="en-US" b="false" i="false" strike="noStrike" u="none" sz="1400">
-                <a:solidFill>
-                  <a:srgbClr val="000000"/>
-                </a:solidFill>
-              </a:rPr>
-              <a:t>The talk follows the logic of a proposal: context, gap, questions, design, and contribution.</a:t>
-            </a:r>
-          </a:p>
-          <a:p>
-            <a:pPr algn="l" marL="0" indent="0">
-              <a:lnSpc>
-                <a:spcPct val="100000"/>
-              </a:lnSpc>
-            </a:pPr>
-            <a:r>
-              <a:rPr lang="en-US" b="false" i="false" strike="noStrike" u="none" sz="1400">
-                <a:solidFill>
-                  <a:srgbClr val="000000"/>
-                </a:solidFill>
-              </a:rPr>
-              <a:t>I will spend most time on the gap, the research questions, and why a qualitative case design is the right way to answer them.</a:t>
-            </a:r>
+              <a:t>This talk follows proposal logic: context, gap, questions, design, contribution.</a:t>
+            </a:r>
+            <a:br/>
+            <a:br/>
+            <a:r>
+              <a:t>I will spend most time on three things: the gap, the research questions, and why observation plus materials comparison is required. The later slides on chapters and innovations can be taken more quickly.</a:t>
+            </a:r>
+            <a:br/>
           </a:p>
         </p:txBody>
       </p:sp>
@@ -3562,43 +3323,19 @@
               </a:lnSpc>
             </a:pPr>
             <a:r>
-              <a:rPr lang="en-US" b="false" i="false" strike="noStrike" u="none" sz="1400">
-                <a:solidFill>
-                  <a:srgbClr val="000000"/>
-                </a:solidFill>
-              </a:rPr>
-              <a:t>Chinese language education in Pakistan grew from a single institute in 2005 into a nationwide system driven by Pakistan-China relations and the CPEC.</a:t>
-            </a:r>
-          </a:p>
-          <a:p>
-            <a:pPr algn="l" marL="0" indent="0">
-              <a:lnSpc>
-                <a:spcPct val="100000"/>
-              </a:lnSpc>
-            </a:pPr>
-            <a:r>
-              <a:rPr lang="en-US" b="false" i="false" strike="noStrike" u="none" sz="1400">
-                <a:solidFill>
-                  <a:srgbClr val="000000"/>
-                </a:solidFill>
-              </a:rPr>
-              <a:t>But scale did not produce a uniform classroom. Existing studies already show that policy on paper and the lived classroom diverge, and that learners struggle.</a:t>
-            </a:r>
-          </a:p>
-          <a:p>
-            <a:pPr algn="l" marL="0" indent="0">
-              <a:lnSpc>
-                <a:spcPct val="100000"/>
-              </a:lnSpc>
-            </a:pPr>
-            <a:r>
-              <a:rPr lang="en-US" b="false" i="false" strike="noStrike" u="none" sz="1400">
-                <a:solidFill>
-                  <a:srgbClr val="000000"/>
-                </a:solidFill>
-              </a:rPr>
-              <a:t>The question is no longer whether learners struggle, but exactly what they are struggling through.</a:t>
-            </a:r>
+              <a:t>This slide is landscape only. It is not the research object.</a:t>
+            </a:r>
+            <a:br/>
+            <a:br/>
+            <a:r>
+              <a:t>Chinese-language education in Pakistan grew from one Confucius Institute in 2005 into a mixed system of degree, required, elective, and short courses. Existing studies already show that policy on paper and classroom reality diverge, and that Chinese enters a multilingual setting.</a:t>
+            </a:r>
+            <a:br/>
+            <a:br/>
+            <a:r>
+              <a:t>Learner difficulty is cited only as a condition teachers meet. This study does not become a study of student beliefs.</a:t>
+            </a:r>
+            <a:br/>
           </a:p>
         </p:txBody>
       </p:sp>
@@ -3817,58 +3554,19 @@
               </a:lnSpc>
             </a:pPr>
             <a:r>
-              <a:rPr lang="en-US" b="false" i="false" strike="noStrike" u="none" sz="1400">
-                <a:solidFill>
-                  <a:srgbClr val="000000"/>
-                </a:solidFill>
-              </a:rPr>
-              <a:t>Pakistani research has already documented that imported, HSK-oriented textbooks do not fit local learners well.</a:t>
-            </a:r>
-          </a:p>
-          <a:p>
-            <a:pPr algn="l" marL="0" indent="0">
-              <a:lnSpc>
-                <a:spcPct val="100000"/>
-              </a:lnSpc>
-            </a:pPr>
-            <a:r>
-              <a:rPr lang="en-US" b="false" i="false" strike="noStrike" u="none" sz="1400">
-                <a:solidFill>
-                  <a:srgbClr val="000000"/>
-                </a:solidFill>
-              </a:rPr>
-              <a:t>The recommended fixes are all to build something new: a localized textbook, revised modules, better training.</a:t>
-            </a:r>
-          </a:p>
-          <a:p>
-            <a:pPr algn="l" marL="0" indent="0">
-              <a:lnSpc>
-                <a:spcPct val="100000"/>
-              </a:lnSpc>
-            </a:pPr>
-            <a:r>
-              <a:rPr lang="en-US" b="false" i="false" strike="noStrike" u="none" sz="1400">
-                <a:solidFill>
-                  <a:srgbClr val="000000"/>
-                </a:solidFill>
-              </a:rPr>
-              <a:t>But those take years. In the meantime, every teacher in front of a class is already making real-time decisions about that book.</a:t>
-            </a:r>
-          </a:p>
-          <a:p>
-            <a:pPr algn="l" marL="0" indent="0">
-              <a:lnSpc>
-                <a:spcPct val="100000"/>
-              </a:lnSpc>
-            </a:pPr>
-            <a:r>
-              <a:rPr lang="en-US" b="false" i="false" strike="noStrike" u="none" sz="1400">
-                <a:solidFill>
-                  <a:srgbClr val="000000"/>
-                </a:solidFill>
-              </a:rPr>
-              <a:t>My study observes those decisions rather than waiting for a book that does not yet exist.</a:t>
-            </a:r>
+              <a:t>Pakistan CFL research reports perceived misfit and then recommends a new book, Urdu modules, or stronger training. Those are product-side answers. They take years to reach a class.</a:t>
+            </a:r>
+            <a:br/>
+            <a:br/>
+            <a:r>
+              <a:t>While that book is being written, teachers still teach with the materials in front of them. They may translate, add an example, skip a section, or teach the page as written. All of those are data.</a:t>
+            </a:r>
+            <a:br/>
+            <a:br/>
+            <a:r>
+              <a:t>The study begins from that present work. It does not begin from a book that does not yet exist. HSK may appear as a condition of that work. It is not the object of the study.</a:t>
+            </a:r>
+            <a:br/>
           </a:p>
         </p:txBody>
       </p:sp>
@@ -4087,43 +3785,29 @@
               </a:lnSpc>
             </a:pPr>
             <a:r>
-              <a:rPr lang="en-US" b="false" i="false" strike="noStrike" u="none" sz="1400">
-                <a:solidFill>
-                  <a:srgbClr val="000000"/>
-                </a:solidFill>
-              </a:rPr>
-              <a:t>I use three terms deliberately and keep them distinct.</a:t>
-            </a:r>
-          </a:p>
-          <a:p>
-            <a:pPr algn="l" marL="0" indent="0">
-              <a:lnSpc>
-                <a:spcPct val="100000"/>
-              </a:lnSpc>
-            </a:pPr>
-            <a:r>
-              <a:rPr lang="en-US" b="false" i="false" strike="noStrike" u="none" sz="1400">
-                <a:solidFill>
-                  <a:srgbClr val="000000"/>
-                </a:solidFill>
-              </a:rPr>
-              <a:t>Recontextualization is the mechanism visible when materials are in use. Localization is one possible outcome of that mechanism, the one the local field already names.</a:t>
-            </a:r>
-          </a:p>
-          <a:p>
-            <a:pPr algn="l" marL="0" indent="0">
-              <a:lnSpc>
-                <a:spcPct val="100000"/>
-              </a:lnSpc>
-            </a:pPr>
-            <a:r>
-              <a:rPr lang="en-US" b="false" i="false" strike="noStrike" u="none" sz="1400">
-                <a:solidFill>
-                  <a:srgbClr val="000000"/>
-                </a:solidFill>
-              </a:rPr>
-              <a:t>The critical point is that motive, not surface change, decides whether a move is localization. A teacher who skips a section to meet the exam schedule is still recontextualizing, but not localizing.</a:t>
-            </a:r>
+              <a:t>Three terms have to stay apart.</a:t>
+            </a:r>
+            <a:br/>
+            <a:br/>
+            <a:r>
+              <a:t>Recontextualization is the pedagogic mechanism: what happens to the published page in class.</a:t>
+            </a:r>
+            <a:br/>
+            <a:br/>
+            <a:r>
+              <a:t>Ecological teacher agency is the achievement that makes that mechanism possible, restricted, or redirected. It is not a personality trait.</a:t>
+            </a:r>
+            <a:br/>
+            <a:br/>
+            <a:r>
+              <a:t>Localization is the name the Pakistan conversation already uses. In this study it is the process or outcome when recontextualization orients materials toward a Pakistani classroom. It is not a third theory, not a pre-set goal, and not a test of whether the lesson was better.</a:t>
+            </a:r>
+            <a:br/>
+            <a:br/>
+            <a:r>
+              <a:t>Why a teacher did it is Research Question 2. It is not another word for agency, and it is not the test of localization. A teacher may recontextualize only to finish a syllabus on time. That is still recontextualization. It is localization only if the work orients the materials toward that Pakistani classroom.</a:t>
+            </a:r>
+            <a:br/>
           </a:p>
         </p:txBody>
       </p:sp>
@@ -4342,43 +4026,19 @@
               </a:lnSpc>
             </a:pPr>
             <a:r>
-              <a:rPr lang="en-US" b="false" i="false" strike="noStrike" u="none" sz="1400">
-                <a:solidFill>
-                  <a:srgbClr val="000000"/>
-                </a:solidFill>
-              </a:rPr>
-              <a:t>The literature is rich, but it fails at the join of object, population and method.</a:t>
-            </a:r>
-          </a:p>
-          <a:p>
-            <a:pPr algn="l" marL="0" indent="0">
-              <a:lnSpc>
-                <a:spcPct val="100000"/>
-              </a:lnSpc>
-            </a:pPr>
-            <a:r>
-              <a:rPr lang="en-US" b="false" i="false" strike="noStrike" u="none" sz="1400">
-                <a:solidFill>
-                  <a:srgbClr val="000000"/>
-                </a:solidFill>
-              </a:rPr>
-              <a:t>Materials-in-use research exists, but not on Pakistani teachers with HSK books. Ecological agency research exists, but mostly with EFL teachers in China and Vietnam. Pakistani CFL research exists, but it relies on surveys and interviews about fit, not on classroom observation.</a:t>
-            </a:r>
-          </a:p>
-          <a:p>
-            <a:pPr algn="l" marL="0" indent="0">
-              <a:lnSpc>
-                <a:spcPct val="100000"/>
-              </a:lnSpc>
-            </a:pPr>
-            <a:r>
-              <a:rPr lang="en-US" b="false" i="false" strike="noStrike" u="none" sz="1400">
-                <a:solidFill>
-                  <a:srgbClr val="000000"/>
-                </a:solidFill>
-              </a:rPr>
-              <a:t>No study has yet combined classroom observation with materials comparison to show how localization is produced in everyday Pakistani teaching.</a:t>
-            </a:r>
+              <a:t>The literature is not empty. It fails, for this title, at the join of object, population, and method.</a:t>
+            </a:r>
+            <a:br/>
+            <a:br/>
+            <a:r>
+              <a:t>Materials-in-use research exists, mainly in ELT. Ecological agency research exists, mainly with EFL teachers in China and Vietnam. CFL localization research often analyses the book as a product. Pakistan CFL research exists, but it is programme description, survey, and interview about fit.</a:t>
+            </a:r>
+            <a:br/>
+            <a:br/>
+            <a:r>
+              <a:t>In the mapped literature, no study of Pakistani teachers of Chinese has joined classroom observation with a comparison of the prescribed page and what was taught. I do not claim a world first. A full CNKI search is still required.</a:t>
+            </a:r>
+            <a:br/>
           </a:p>
         </p:txBody>
       </p:sp>
@@ -4597,43 +4257,24 @@
               </a:lnSpc>
             </a:pPr>
             <a:r>
-              <a:rPr lang="en-US" b="false" i="false" strike="noStrike" u="none" sz="1400">
-                <a:solidFill>
-                  <a:srgbClr val="000000"/>
-                </a:solidFill>
-              </a:rPr>
-              <a:t>The core question names the two objects the thesis studies together: materials recontextualization and teacher agency.</a:t>
-            </a:r>
-          </a:p>
-          <a:p>
-            <a:pPr algn="l" marL="0" indent="0">
-              <a:lnSpc>
-                <a:spcPct val="100000"/>
-              </a:lnSpc>
-            </a:pPr>
-            <a:r>
-              <a:rPr lang="en-US" b="false" i="false" strike="noStrike" u="none" sz="1400">
-                <a:solidFill>
-                  <a:srgbClr val="000000"/>
-                </a:solidFill>
-              </a:rPr>
-              <a:t>RQ1 asks what teachers actually do. RQ2 asks how they justify it. RQ3 asks how surrounding conditions open or close space for that work.</a:t>
-            </a:r>
-          </a:p>
-          <a:p>
-            <a:pPr algn="l" marL="0" indent="0">
-              <a:lnSpc>
-                <a:spcPct val="100000"/>
-              </a:lnSpc>
-            </a:pPr>
-            <a:r>
-              <a:rPr lang="en-US" b="false" i="false" strike="noStrike" u="none" sz="1400">
-                <a:solidFill>
-                  <a:srgbClr val="000000"/>
-                </a:solidFill>
-              </a:rPr>
-              <a:t>Faithful transmission is included deliberately — sticking to the book under exam pressure is still a recontextualizing choice, not a failure to make one.</a:t>
-            </a:r>
+              <a:t>The core question names the two objects in the title: recontextualization of materials, and teacher agency.</a:t>
+            </a:r>
+            <a:br/>
+            <a:br/>
+            <a:r>
+              <a:t>RQ1 asks what teachers do, including faithful transmission. Following the book under exam pressure is still a recontextualizing choice. It is not coded in advance as a lack of agency.</a:t>
+            </a:r>
+            <a:br/>
+            <a:br/>
+            <a:r>
+              <a:t>RQ2 asks how they justify those decisions. Why is practical-evaluative reasoning. It is not a synonym for agency.</a:t>
+            </a:r>
+            <a:br/>
+            <a:br/>
+            <a:r>
+              <a:t>RQ3 asks how agency is achieved, restricted, or redirected, and which nested conditions open or close room to manoeuvre. HSK appears here as policy and assessment, not as a book to be scored.</a:t>
+            </a:r>
+            <a:br/>
           </a:p>
         </p:txBody>
       </p:sp>
@@ -4852,43 +4493,24 @@
               </a:lnSpc>
             </a:pPr>
             <a:r>
-              <a:rPr lang="en-US" b="false" i="false" strike="noStrike" u="none" sz="1400">
-                <a:solidFill>
-                  <a:srgbClr val="000000"/>
-                </a:solidFill>
-              </a:rPr>
-              <a:t>Two theories are joined. Recontextualization names the pedagogic mechanism visible once materials are in use.</a:t>
-            </a:r>
-          </a:p>
-          <a:p>
-            <a:pPr algn="l" marL="0" indent="0">
-              <a:lnSpc>
-                <a:spcPct val="100000"/>
-              </a:lnSpc>
-            </a:pPr>
-            <a:r>
-              <a:rPr lang="en-US" b="false" i="false" strike="noStrike" u="none" sz="1400">
-                <a:solidFill>
-                  <a:srgbClr val="000000"/>
-                </a:solidFill>
-              </a:rPr>
-              <a:t>Ecological agency explains whether, and how much, a teacher can act on that mechanism: agency is not a personal trait but an achievement, sounded together across the teacher's past, future aims, and present judgement.</a:t>
-            </a:r>
-          </a:p>
-          <a:p>
-            <a:pPr algn="l" marL="0" indent="0">
-              <a:lnSpc>
-                <a:spcPct val="100000"/>
-              </a:lnSpc>
-            </a:pPr>
-            <a:r>
-              <a:rPr lang="en-US" b="false" i="false" strike="noStrike" u="none" sz="1400">
-                <a:solidFill>
-                  <a:srgbClr val="000000"/>
-                </a:solidFill>
-              </a:rPr>
-              <a:t>All of this sits inside nested conditions — from the classroom up to HSK policy and the wider society. The same teacher may recontextualize freely in one class and stay textbook-tied in another, because those conditions differ.</a:t>
-            </a:r>
+              <a:t>Two working concepts, not three.</a:t>
+            </a:r>
+            <a:br/>
+            <a:br/>
+            <a:r>
+              <a:t>Recontextualization names the mechanism, following Bernstein and materials-in-use research. The classroom is a further site, not the first one. An HSK-oriented series already arrives as an official selection.</a:t>
+            </a:r>
+            <a:br/>
+            <a:br/>
+            <a:r>
+              <a:t>Ecological agency, following Biesta and Tedder and Priestley, Biesta, and Robinson, is an achievement in context: past experience, future purpose, and present judgement sounding together.</a:t>
+            </a:r>
+            <a:br/>
+            <a:br/>
+            <a:r>
+              <a:t>Nested conditions are part of that achievement: classroom and materials, institution, assessment and HSK policy, profession, and the wider setting. Localization is not a third box in this figure.</a:t>
+            </a:r>
+            <a:br/>
           </a:p>
         </p:txBody>
       </p:sp>
@@ -5107,43 +4729,19 @@
               </a:lnSpc>
             </a:pPr>
             <a:r>
-              <a:rPr lang="en-US" b="false" i="false" strike="noStrike" u="none" sz="1400">
-                <a:solidFill>
-                  <a:srgbClr val="000000"/>
-                </a:solidFill>
-              </a:rPr>
-              <a:t>The object — meaning made in context — calls for case study work. I follow several teachers rather than one, because agency shifts with institutional conditions.</a:t>
-            </a:r>
-          </a:p>
-          <a:p>
-            <a:pPr algn="l" marL="0" indent="0">
-              <a:lnSpc>
-                <a:spcPct val="100000"/>
-              </a:lnSpc>
-            </a:pPr>
-            <a:r>
-              <a:rPr lang="en-US" b="false" i="false" strike="noStrike" u="none" sz="1400">
-                <a:solidFill>
-                  <a:srgbClr val="000000"/>
-                </a:solidFill>
-              </a:rPr>
-              <a:t>A questionnaire would simply repeat what Lu, Hanif and Naheed already did, and would reproduce the known gap between what teachers report and what they do.</a:t>
-            </a:r>
-          </a:p>
-          <a:p>
-            <a:pPr algn="l" marL="0" indent="0">
-              <a:lnSpc>
-                <a:spcPct val="100000"/>
-              </a:lnSpc>
-            </a:pPr>
-            <a:r>
-              <a:rPr lang="en-US" b="false" i="false" strike="noStrike" u="none" sz="1400">
-                <a:solidFill>
-                  <a:srgbClr val="000000"/>
-                </a:solidFill>
-              </a:rPr>
-              <a:t>The study is therefore explicit about what it is not: it is not scoring the HSK series, and it does not produce a new textbook.</a:t>
-            </a:r>
+              <a:t>The object is practice in context, so the design is an interpretive qualitative multiple-case study. About six to eight teachers, two to three lessons each, revised after a pilot. Depth and page comparison matter more than counting more teachers.</a:t>
+            </a:r>
+            <a:br/>
+            <a:br/>
+            <a:r>
+              <a:t>A questionnaire would repeat Lu, Hanif, and Naheed, and would reproduce the known gap between what teachers report and what they do.</a:t>
+            </a:r>
+            <a:br/>
+            <a:br/>
+            <a:r>
+              <a:t>The study is not an HSK product evaluation. It is not needs analysis. It does not produce a new textbook as the doctoral output.</a:t>
+            </a:r>
+            <a:br/>
           </a:p>
         </p:txBody>
       </p:sp>

</xml_diff>

<commit_message>
Fix slide 5 oral wording on localization.
Localization is orientation toward a Pakistani classroom, not a test
of motive. Speaker notes now match that cut and keep RQ2 and agency
apart.

Co-authored-by: kristinehina23-rgb <kristinehina23-rgb@users.noreply.github.com>
</commit_message>
<xml_diff>
--- a/proposal/PhD-research-proposal.pptx
+++ b/proposal/PhD-research-proposal.pptx
@@ -3785,27 +3785,22 @@
               </a:lnSpc>
             </a:pPr>
             <a:r>
-              <a:t>Three terms have to stay apart.</a:t>
+              <a:t>Before the literature, I keep two terms apart. They are used loosely in this field. The difference shapes my questions.</a:t>
             </a:r>
             <a:br/>
             <a:br/>
             <a:r>
-              <a:t>Recontextualization is the pedagogic mechanism: what happens to the published page in class.</a:t>
+              <a:t>Recontextualization, following Bernstein, is the process by which teaching materials are selected, relocated, and refocused as they move into an actual classroom. In this study it names the mechanism: what teachers do with the page. That can be translation, cutting, substitution, reordering, or a quieter shift in emphasis and student participation.</a:t>
             </a:r>
             <a:br/>
             <a:br/>
             <a:r>
-              <a:t>Ecological teacher agency is the achievement that makes that mechanism possible, restricted, or redirected. It is not a personality trait.</a:t>
+              <a:t>Localization is not a third theory. It is one possible outcome of recontextualization: when that work orients the materials toward a Pakistani classroom. The two are related, but they are not the same. A teacher may recontextualize only to finish a syllabus on time. That is still recontextualization. It is localization only if the work turns the page toward that Pakistani class.</a:t>
             </a:r>
             <a:br/>
             <a:br/>
             <a:r>
-              <a:t>Localization is the name the Pakistan conversation already uses. In this study it is the process or outcome when recontextualization orients materials toward a Pakistani classroom. It is not a third theory, not a pre-set goal, and not a test of whether the lesson was better.</a:t>
-            </a:r>
-            <a:br/>
-            <a:br/>
-            <a:r>
-              <a:t>Why a teacher did it is Research Question 2. It is not another word for agency, and it is not the test of localization. A teacher may recontextualize only to finish a syllabus on time. That is still recontextualization. It is localization only if the work orients the materials toward that Pakistani classroom.</a:t>
+              <a:t>Why the teacher did it is Research Question 2. I do not assume the reason in advance. That "why" is not the test of localization, and it is not another word for teacher agency. Agency is the third term. It comes on the next theory slide.</a:t>
             </a:r>
             <a:br/>
           </a:p>
@@ -26032,7 +26027,7 @@
                 <a:cs typeface="Lora"/>
                 <a:sym typeface="Lora"/>
               </a:rPr>
-              <a:t>The name the Pakistan conversation already uses. It applies when recontextualization happens to orient the materials toward Pakistani learners and their context.</a:t>
+              <a:t>The name the Pakistan conversation already uses. It applies when recontextualization orients the materials toward Pakistani learners and their context.</a:t>
             </a:r>
             <a:endParaRPr lang="en-US" sz="1100"/>
           </a:p>

</xml_diff>